<commit_message>
Fix Ch02 slides 10/11/12/13 text cut and overlap
- Slide 10: row content overflowed 0.86 boxes; restructured to h=0.94
  with y spacing 1.0, trimmed verbose EN descriptions to 1 line each
- Slide 11: context text 4-line overflow pushed into types boxes;
  shortened text to 2 lines, h 0.75→0.72, types y 2.05→2.08 h 2.62,
  bottom caption y 4.92→4.82
- Slide 12: subtitle cut by rule at 1.06; split to 2 lines h=0.52,
  rule→1.24, header→1.30, rows→1.72 with spacing 0.40
- Slide 13: syllable boxes overlapped description EN line;
  description h 0.55→0.72, syllables y 2.35→2.52, bottom 3.35→3.45

Co-Authored-By: Claude Opus 4.7 <noreply@anthropic.com>
</commit_message>
<xml_diff>
--- a/Ch02_Christian_Church.pptx
+++ b/Ch02_Christian_Church.pptx
@@ -2588,8 +2588,8 @@
         </p:nvSpPr>
         <p:spPr>
           <a:xfrm>
-            <a:off x="274320" y="1298448"/>
-            <a:ext cx="8595360" cy="786384"/>
+            <a:off x="274320" y="1261872"/>
+            <a:ext cx="8595360" cy="859536"/>
           </a:xfrm>
           <a:prstGeom prst="rect">
             <a:avLst/>
@@ -2608,17 +2608,17 @@
         </p:nvSpPr>
         <p:spPr>
           <a:xfrm>
-            <a:off x="411480" y="1353312"/>
-            <a:ext cx="2194560" cy="658368"/>
-          </a:xfrm>
-          <a:prstGeom prst="rect">
-            <a:avLst/>
-          </a:prstGeom>
-          <a:noFill/>
-          <a:ln/>
-        </p:spPr>
-        <p:txBody>
-          <a:bodyPr wrap="square" lIns="0" tIns="0" rIns="0" bIns="0" rtlCol="0" anchor="ctr"/>
+            <a:off x="411480" y="1325880"/>
+            <a:ext cx="2377440" cy="731520"/>
+          </a:xfrm>
+          <a:prstGeom prst="rect">
+            <a:avLst/>
+          </a:prstGeom>
+          <a:noFill/>
+          <a:ln/>
+        </p:spPr>
+        <p:txBody>
+          <a:bodyPr wrap="square" lIns="0" tIns="0" rIns="0" bIns="0" rtlCol="0" anchor="t"/>
           <a:lstStyle/>
           <a:p>
             <a:pPr indent="0" marL="0">
@@ -2664,8 +2664,8 @@
         </p:nvSpPr>
         <p:spPr>
           <a:xfrm>
-            <a:off x="2697480" y="1408176"/>
-            <a:ext cx="36576" cy="548640"/>
+            <a:off x="2880360" y="1353312"/>
+            <a:ext cx="36576" cy="658368"/>
           </a:xfrm>
           <a:prstGeom prst="rect">
             <a:avLst/>
@@ -2684,8 +2684,8 @@
         </p:nvSpPr>
         <p:spPr>
           <a:xfrm>
-            <a:off x="2816352" y="1362456"/>
-            <a:ext cx="5943600" cy="658368"/>
+            <a:off x="2999232" y="1307592"/>
+            <a:ext cx="5715000" cy="804672"/>
           </a:xfrm>
           <a:prstGeom prst="rect">
             <a:avLst/>
@@ -2709,7 +2709,7 @@
                 <a:ea typeface="Calibri" pitchFamily="34" charset="-122"/>
                 <a:cs typeface="Calibri" pitchFamily="34" charset="-120"/>
               </a:rPr>
-              <a:t>記譜法出現前，聖詠靠口傳記憶；歌手學習數以百計的旋律，全靠記憶</a:t>
+              <a:t>記譜法出現前，聖詠靠口傳記憶；歌手須記數百旋律</a:t>
             </a:r>
             <a:endParaRPr lang="en-US" sz="1400" dirty="0"/>
           </a:p>
@@ -2726,7 +2726,7 @@
                 <a:ea typeface="Calibri" pitchFamily="34" charset="-122"/>
                 <a:cs typeface="Calibri" pitchFamily="34" charset="-120"/>
               </a:rPr>
-              <a:t>Before notation, chants were memorized through oral transmission; singers memorized hundreds of melodies</a:t>
+              <a:t>Before notation, chants memorized orally; hundreds of melodies</a:t>
             </a:r>
             <a:endParaRPr lang="en-US" sz="1400" dirty="0"/>
           </a:p>
@@ -2740,8 +2740,8 @@
         </p:nvSpPr>
         <p:spPr>
           <a:xfrm>
-            <a:off x="274320" y="2194560"/>
-            <a:ext cx="8595360" cy="786384"/>
+            <a:off x="274320" y="2176272"/>
+            <a:ext cx="8595360" cy="859536"/>
           </a:xfrm>
           <a:prstGeom prst="rect">
             <a:avLst/>
@@ -2760,17 +2760,17 @@
         </p:nvSpPr>
         <p:spPr>
           <a:xfrm>
-            <a:off x="411480" y="2249424"/>
-            <a:ext cx="2194560" cy="658368"/>
-          </a:xfrm>
-          <a:prstGeom prst="rect">
-            <a:avLst/>
-          </a:prstGeom>
-          <a:noFill/>
-          <a:ln/>
-        </p:spPr>
-        <p:txBody>
-          <a:bodyPr wrap="square" lIns="0" tIns="0" rIns="0" bIns="0" rtlCol="0" anchor="ctr"/>
+            <a:off x="411480" y="2240280"/>
+            <a:ext cx="2377440" cy="731520"/>
+          </a:xfrm>
+          <a:prstGeom prst="rect">
+            <a:avLst/>
+          </a:prstGeom>
+          <a:noFill/>
+          <a:ln/>
+        </p:spPr>
+        <p:txBody>
+          <a:bodyPr wrap="square" lIns="0" tIns="0" rIns="0" bIns="0" rtlCol="0" anchor="t"/>
           <a:lstStyle/>
           <a:p>
             <a:pPr indent="0" marL="0">
@@ -2816,8 +2816,8 @@
         </p:nvSpPr>
         <p:spPr>
           <a:xfrm>
-            <a:off x="2697480" y="2304288"/>
-            <a:ext cx="36576" cy="548640"/>
+            <a:off x="2880360" y="2267712"/>
+            <a:ext cx="36576" cy="658368"/>
           </a:xfrm>
           <a:prstGeom prst="rect">
             <a:avLst/>
@@ -2836,8 +2836,8 @@
         </p:nvSpPr>
         <p:spPr>
           <a:xfrm>
-            <a:off x="2816352" y="2258568"/>
-            <a:ext cx="5943600" cy="658368"/>
+            <a:off x="2999232" y="2221992"/>
+            <a:ext cx="5715000" cy="804672"/>
           </a:xfrm>
           <a:prstGeom prst="rect">
             <a:avLst/>
@@ -2861,7 +2861,7 @@
                 <a:ea typeface="Calibri" pitchFamily="34" charset="-122"/>
                 <a:cs typeface="Calibri" pitchFamily="34" charset="-120"/>
               </a:rPr>
-              <a:t>寫在文字上方的記號（gesture/shape），提示旋律輪廓——但不指定確切音高</a:t>
+              <a:t>文字上方記號（gesture/shape），提示旋律輪廓但不定音高</a:t>
             </a:r>
             <a:endParaRPr lang="en-US" sz="1400" dirty="0"/>
           </a:p>
@@ -2878,7 +2878,7 @@
                 <a:ea typeface="Calibri" pitchFamily="34" charset="-122"/>
                 <a:cs typeface="Calibri" pitchFamily="34" charset="-120"/>
               </a:rPr>
-              <a:t>Signs placed above text to indicate melodic contour—direction, shape—but not precise pitches or intervals</a:t>
+              <a:t>Signs above text show melodic contour — no precise pitch</a:t>
             </a:r>
             <a:endParaRPr lang="en-US" sz="1400" dirty="0"/>
           </a:p>
@@ -2893,7 +2893,7 @@
         <p:spPr>
           <a:xfrm>
             <a:off x="274320" y="3090672"/>
-            <a:ext cx="8595360" cy="786384"/>
+            <a:ext cx="8595360" cy="859536"/>
           </a:xfrm>
           <a:prstGeom prst="rect">
             <a:avLst/>
@@ -2912,17 +2912,17 @@
         </p:nvSpPr>
         <p:spPr>
           <a:xfrm>
-            <a:off x="411480" y="3145536"/>
-            <a:ext cx="2194560" cy="658368"/>
-          </a:xfrm>
-          <a:prstGeom prst="rect">
-            <a:avLst/>
-          </a:prstGeom>
-          <a:noFill/>
-          <a:ln/>
-        </p:spPr>
-        <p:txBody>
-          <a:bodyPr wrap="square" lIns="0" tIns="0" rIns="0" bIns="0" rtlCol="0" anchor="ctr"/>
+            <a:off x="411480" y="3154680"/>
+            <a:ext cx="2377440" cy="731520"/>
+          </a:xfrm>
+          <a:prstGeom prst="rect">
+            <a:avLst/>
+          </a:prstGeom>
+          <a:noFill/>
+          <a:ln/>
+        </p:spPr>
+        <p:txBody>
+          <a:bodyPr wrap="square" lIns="0" tIns="0" rIns="0" bIns="0" rtlCol="0" anchor="t"/>
           <a:lstStyle/>
           <a:p>
             <a:pPr indent="0" marL="0">
@@ -2968,8 +2968,8 @@
         </p:nvSpPr>
         <p:spPr>
           <a:xfrm>
-            <a:off x="2697480" y="3200400"/>
-            <a:ext cx="36576" cy="548640"/>
+            <a:off x="2880360" y="3182112"/>
+            <a:ext cx="36576" cy="658368"/>
           </a:xfrm>
           <a:prstGeom prst="rect">
             <a:avLst/>
@@ -2988,8 +2988,8 @@
         </p:nvSpPr>
         <p:spPr>
           <a:xfrm>
-            <a:off x="2816352" y="3154680"/>
-            <a:ext cx="5943600" cy="658368"/>
+            <a:off x="2999232" y="3136392"/>
+            <a:ext cx="5715000" cy="804672"/>
           </a:xfrm>
           <a:prstGeom prst="rect">
             <a:avLst/>
@@ -3013,7 +3013,7 @@
                 <a:ea typeface="Calibri" pitchFamily="34" charset="-122"/>
                 <a:cs typeface="Calibri" pitchFamily="34" charset="-120"/>
               </a:rPr>
-              <a:t>紐姆符號寫在不同高度以指示音高；加一條橫線輔助辨識音高（音高相對但仍不確定）</a:t>
+              <a:t>紐姆寫在不同高度以指示音高；加一條橫線輔助辨識</a:t>
             </a:r>
             <a:endParaRPr lang="en-US" sz="1400" dirty="0"/>
           </a:p>
@@ -3030,7 +3030,7 @@
                 <a:ea typeface="Calibri" pitchFamily="34" charset="-122"/>
                 <a:cs typeface="Calibri" pitchFamily="34" charset="-120"/>
               </a:rPr>
-              <a:t>Neumes placed at varying heights above text to indicate relative pitch; a scratched line helped identify one note</a:t>
+              <a:t>Neumes at varying heights show relative pitch; one scratched line added</a:t>
             </a:r>
             <a:endParaRPr lang="en-US" sz="1400" dirty="0"/>
           </a:p>
@@ -3044,8 +3044,8 @@
         </p:nvSpPr>
         <p:spPr>
           <a:xfrm>
-            <a:off x="274320" y="3986784"/>
-            <a:ext cx="8595360" cy="786384"/>
+            <a:off x="274320" y="4005072"/>
+            <a:ext cx="8595360" cy="859536"/>
           </a:xfrm>
           <a:prstGeom prst="rect">
             <a:avLst/>
@@ -3064,17 +3064,17 @@
         </p:nvSpPr>
         <p:spPr>
           <a:xfrm>
-            <a:off x="411480" y="4041648"/>
-            <a:ext cx="2194560" cy="658368"/>
-          </a:xfrm>
-          <a:prstGeom prst="rect">
-            <a:avLst/>
-          </a:prstGeom>
-          <a:noFill/>
-          <a:ln/>
-        </p:spPr>
-        <p:txBody>
-          <a:bodyPr wrap="square" lIns="0" tIns="0" rIns="0" bIns="0" rtlCol="0" anchor="ctr"/>
+            <a:off x="411480" y="4069080"/>
+            <a:ext cx="2377440" cy="731520"/>
+          </a:xfrm>
+          <a:prstGeom prst="rect">
+            <a:avLst/>
+          </a:prstGeom>
+          <a:noFill/>
+          <a:ln/>
+        </p:spPr>
+        <p:txBody>
+          <a:bodyPr wrap="square" lIns="0" tIns="0" rIns="0" bIns="0" rtlCol="0" anchor="t"/>
           <a:lstStyle/>
           <a:p>
             <a:pPr indent="0" marL="0">
@@ -3120,8 +3120,8 @@
         </p:nvSpPr>
         <p:spPr>
           <a:xfrm>
-            <a:off x="2697480" y="4096512"/>
-            <a:ext cx="36576" cy="548640"/>
+            <a:off x="2880360" y="4096512"/>
+            <a:ext cx="36576" cy="658368"/>
           </a:xfrm>
           <a:prstGeom prst="rect">
             <a:avLst/>
@@ -3140,8 +3140,8 @@
         </p:nvSpPr>
         <p:spPr>
           <a:xfrm>
-            <a:off x="2816352" y="4050792"/>
-            <a:ext cx="5943600" cy="658368"/>
+            <a:off x="2999232" y="4050792"/>
+            <a:ext cx="5715000" cy="804672"/>
           </a:xfrm>
           <a:prstGeom prst="rect">
             <a:avLst/>
@@ -3165,7 +3165,7 @@
                 <a:ea typeface="Calibri" pitchFamily="34" charset="-122"/>
                 <a:cs typeface="Calibri" pitchFamily="34" charset="-120"/>
               </a:rPr>
-              <a:t>阿雷佐的桂多（ca. 991–1033）：四線譜，F、C 譜號，紐姆符號改良為精確音符</a:t>
+              <a:t>阿雷佐桂多（ca. 991–1033）：四線譜，F、C 譜號，精確音符</a:t>
             </a:r>
             <a:endParaRPr lang="en-US" sz="1400" dirty="0"/>
           </a:p>
@@ -3182,7 +3182,7 @@
                 <a:ea typeface="Calibri" pitchFamily="34" charset="-122"/>
                 <a:cs typeface="Calibri" pitchFamily="34" charset="-120"/>
               </a:rPr>
-              <a:t>Guido of Arezzo: four-line staff with F and C clefs; neumes reshaped to indicate pitch exactly; music could now be read at sight</a:t>
+              <a:t>Guido of Arezzo: four-line staff with F/C clefs — precise pitch</a:t>
             </a:r>
             <a:endParaRPr lang="en-US" sz="1400" dirty="0"/>
           </a:p>
@@ -3367,7 +3367,7 @@
         <p:spPr>
           <a:xfrm>
             <a:off x="365760" y="1078992"/>
-            <a:ext cx="8412480" cy="685800"/>
+            <a:ext cx="8412480" cy="658368"/>
           </a:xfrm>
           <a:prstGeom prst="rect">
             <a:avLst/>
@@ -3391,7 +3391,7 @@
                 <a:ea typeface="Calibri" pitchFamily="34" charset="-122"/>
                 <a:cs typeface="Calibri" pitchFamily="34" charset="-120"/>
               </a:rPr>
-              <a:t>波愛修斯生於羅馬貴族，後受哥德統治者狄奧多里克任命，依據希臘文獻（畢達哥拉斯、托勒密）撰寫《音樂基礎》。此書在中世紀被奉為最高音樂理論權威超過一千年。</a:t>
+              <a:t>波愛修斯依據希臘文獻（畢達哥拉斯、托勒密）撰寫《音樂基礎》，在中世紀被奉為最高音樂理論權威</a:t>
             </a:r>
             <a:endParaRPr lang="en-US" sz="1400" dirty="0"/>
           </a:p>
@@ -3408,7 +3408,7 @@
                 <a:ea typeface="Calibri" pitchFamily="34" charset="-122"/>
                 <a:cs typeface="Calibri" pitchFamily="34" charset="-120"/>
               </a:rPr>
-              <a:t>Boethius, born into Roman nobility, compiled De institutione musica from Greek sources (Pythagoras, Ptolemy). It was the authoritative text on music theory for over a thousand years.</a:t>
+              <a:t>Boethius compiled De institutione musica from Greek sources; authoritative medieval music theory text for a millennium</a:t>
             </a:r>
             <a:endParaRPr lang="en-US" sz="1400" dirty="0"/>
           </a:p>
@@ -3422,8 +3422,8 @@
         </p:nvSpPr>
         <p:spPr>
           <a:xfrm>
-            <a:off x="274320" y="1874520"/>
-            <a:ext cx="2788920" cy="2514600"/>
+            <a:off x="274320" y="1901952"/>
+            <a:ext cx="2788920" cy="2395728"/>
           </a:xfrm>
           <a:prstGeom prst="rect">
             <a:avLst/>
@@ -3442,7 +3442,7 @@
         </p:nvSpPr>
         <p:spPr>
           <a:xfrm>
-            <a:off x="274320" y="1920240"/>
+            <a:off x="274320" y="1947672"/>
             <a:ext cx="2788920" cy="411480"/>
           </a:xfrm>
           <a:prstGeom prst="rect">
@@ -3478,7 +3478,7 @@
         </p:nvSpPr>
         <p:spPr>
           <a:xfrm>
-            <a:off x="365760" y="2331720"/>
+            <a:off x="365760" y="2359152"/>
             <a:ext cx="2606040" cy="548640"/>
           </a:xfrm>
           <a:prstGeom prst="rect">
@@ -3554,8 +3554,8 @@
         </p:nvSpPr>
         <p:spPr>
           <a:xfrm>
-            <a:off x="365760" y="3017520"/>
-            <a:ext cx="2606040" cy="1280160"/>
+            <a:off x="365760" y="2999232"/>
+            <a:ext cx="2606040" cy="1234440"/>
           </a:xfrm>
           <a:prstGeom prst="rect">
             <a:avLst/>
@@ -3610,8 +3610,8 @@
         </p:nvSpPr>
         <p:spPr>
           <a:xfrm>
-            <a:off x="3246120" y="1874520"/>
-            <a:ext cx="2788920" cy="2514600"/>
+            <a:off x="3246120" y="1901952"/>
+            <a:ext cx="2788920" cy="2395728"/>
           </a:xfrm>
           <a:prstGeom prst="rect">
             <a:avLst/>
@@ -3630,7 +3630,7 @@
         </p:nvSpPr>
         <p:spPr>
           <a:xfrm>
-            <a:off x="3246120" y="1920240"/>
+            <a:off x="3246120" y="1947672"/>
             <a:ext cx="2788920" cy="411480"/>
           </a:xfrm>
           <a:prstGeom prst="rect">
@@ -3666,7 +3666,7 @@
         </p:nvSpPr>
         <p:spPr>
           <a:xfrm>
-            <a:off x="3337560" y="2331720"/>
+            <a:off x="3337560" y="2359152"/>
             <a:ext cx="2606040" cy="548640"/>
           </a:xfrm>
           <a:prstGeom prst="rect">
@@ -3742,8 +3742,8 @@
         </p:nvSpPr>
         <p:spPr>
           <a:xfrm>
-            <a:off x="3337560" y="3017520"/>
-            <a:ext cx="2606040" cy="1280160"/>
+            <a:off x="3337560" y="2999232"/>
+            <a:ext cx="2606040" cy="1234440"/>
           </a:xfrm>
           <a:prstGeom prst="rect">
             <a:avLst/>
@@ -3798,8 +3798,8 @@
         </p:nvSpPr>
         <p:spPr>
           <a:xfrm>
-            <a:off x="6217920" y="1874520"/>
-            <a:ext cx="2788920" cy="2514600"/>
+            <a:off x="6217920" y="1901952"/>
+            <a:ext cx="2788920" cy="2395728"/>
           </a:xfrm>
           <a:prstGeom prst="rect">
             <a:avLst/>
@@ -3818,7 +3818,7 @@
         </p:nvSpPr>
         <p:spPr>
           <a:xfrm>
-            <a:off x="6217920" y="1920240"/>
+            <a:off x="6217920" y="1947672"/>
             <a:ext cx="2788920" cy="411480"/>
           </a:xfrm>
           <a:prstGeom prst="rect">
@@ -3854,7 +3854,7 @@
         </p:nvSpPr>
         <p:spPr>
           <a:xfrm>
-            <a:off x="6309360" y="2331720"/>
+            <a:off x="6309360" y="2359152"/>
             <a:ext cx="2606040" cy="548640"/>
           </a:xfrm>
           <a:prstGeom prst="rect">
@@ -3930,8 +3930,8 @@
         </p:nvSpPr>
         <p:spPr>
           <a:xfrm>
-            <a:off x="6309360" y="3017520"/>
-            <a:ext cx="2606040" cy="1280160"/>
+            <a:off x="6309360" y="2999232"/>
+            <a:ext cx="2606040" cy="1234440"/>
           </a:xfrm>
           <a:prstGeom prst="rect">
             <a:avLst/>
@@ -3986,8 +3986,8 @@
         </p:nvSpPr>
         <p:spPr>
           <a:xfrm>
-            <a:off x="365760" y="4498848"/>
-            <a:ext cx="8412480" cy="457200"/>
+            <a:off x="365760" y="4407408"/>
+            <a:ext cx="8412480" cy="530352"/>
           </a:xfrm>
           <a:prstGeom prst="rect">
             <a:avLst/>
@@ -4028,7 +4028,7 @@
                 <a:ea typeface="Calibri" pitchFamily="34" charset="-122"/>
                 <a:cs typeface="Calibri" pitchFamily="34" charset="-120"/>
               </a:rPr>
-              <a:t>For Boethius, music is knowledge, not practice; the true musician understands, not plays</a:t>
+              <a:t>For Boethius, music is knowledge; the true musician understands, not plays</a:t>
             </a:r>
             <a:endParaRPr lang="en-US" sz="1400" dirty="0"/>
           </a:p>
@@ -4154,7 +4154,7 @@
         <p:spPr>
           <a:xfrm>
             <a:off x="365760" y="640080"/>
-            <a:ext cx="8412480" cy="320040"/>
+            <a:ext cx="8412480" cy="475488"/>
           </a:xfrm>
           <a:prstGeom prst="rect">
             <a:avLst/>
@@ -4178,7 +4178,24 @@
                 <a:ea typeface="Calibri" pitchFamily="34" charset="-122"/>
                 <a:cs typeface="Calibri" pitchFamily="34" charset="-120"/>
               </a:rPr>
-              <a:t>源自拜占庭的八種 echoi，是組織與記憶格里高利聖詠的核心工具 · Adapted from Byzantine echoi; central tool for classifying and memorizing Gregorian chant</a:t>
+              <a:t>源自拜占庭的八種 echoi · 組織與記憶格里高利聖詠的核心工具</a:t>
+            </a:r>
+            <a:endParaRPr lang="en-US" sz="1400" dirty="0"/>
+          </a:p>
+          <a:p>
+            <a:pPr indent="0" marL="0">
+              <a:buNone/>
+            </a:pPr>
+            <a:r>
+              <a:rPr lang="en-US" sz="1400" i="1" dirty="0">
+                <a:solidFill>
+                  <a:srgbClr val="5C3A28"/>
+                </a:solidFill>
+                <a:latin typeface="Calibri" pitchFamily="34" charset="0"/>
+                <a:ea typeface="Calibri" pitchFamily="34" charset="-122"/>
+                <a:cs typeface="Calibri" pitchFamily="34" charset="-120"/>
+              </a:rPr>
+              <a:t>Based on Byzantine echoi · central tool for classifying Gregorian chant</a:t>
             </a:r>
             <a:endParaRPr lang="en-US" sz="1400" dirty="0"/>
           </a:p>
@@ -4192,7 +4209,7 @@
         </p:nvSpPr>
         <p:spPr>
           <a:xfrm>
-            <a:off x="365760" y="969264"/>
+            <a:off x="365760" y="1133856"/>
             <a:ext cx="8412480" cy="27432"/>
           </a:xfrm>
           <a:prstGeom prst="rect">
@@ -4212,8 +4229,8 @@
         </p:nvSpPr>
         <p:spPr>
           <a:xfrm>
-            <a:off x="320040" y="1024128"/>
-            <a:ext cx="1920240" cy="365760"/>
+            <a:off x="320040" y="1188720"/>
+            <a:ext cx="1920240" cy="347472"/>
           </a:xfrm>
           <a:prstGeom prst="rect">
             <a:avLst/>
@@ -4232,8 +4249,8 @@
         </p:nvSpPr>
         <p:spPr>
           <a:xfrm>
-            <a:off x="365760" y="1042416"/>
-            <a:ext cx="1874520" cy="329184"/>
+            <a:off x="365760" y="1207008"/>
+            <a:ext cx="1874520" cy="310896"/>
           </a:xfrm>
           <a:prstGeom prst="rect">
             <a:avLst/>
@@ -4271,8 +4288,8 @@
         </p:nvSpPr>
         <p:spPr>
           <a:xfrm>
-            <a:off x="2286000" y="1024128"/>
-            <a:ext cx="960120" cy="365760"/>
+            <a:off x="2286000" y="1188720"/>
+            <a:ext cx="960120" cy="347472"/>
           </a:xfrm>
           <a:prstGeom prst="rect">
             <a:avLst/>
@@ -4291,8 +4308,8 @@
         </p:nvSpPr>
         <p:spPr>
           <a:xfrm>
-            <a:off x="2331720" y="1042416"/>
-            <a:ext cx="914400" cy="329184"/>
+            <a:off x="2331720" y="1207008"/>
+            <a:ext cx="914400" cy="310896"/>
           </a:xfrm>
           <a:prstGeom prst="rect">
             <a:avLst/>
@@ -4330,8 +4347,8 @@
         </p:nvSpPr>
         <p:spPr>
           <a:xfrm>
-            <a:off x="3291840" y="1024128"/>
-            <a:ext cx="1280160" cy="365760"/>
+            <a:off x="3291840" y="1188720"/>
+            <a:ext cx="1280160" cy="347472"/>
           </a:xfrm>
           <a:prstGeom prst="rect">
             <a:avLst/>
@@ -4350,8 +4367,8 @@
         </p:nvSpPr>
         <p:spPr>
           <a:xfrm>
-            <a:off x="3337560" y="1042416"/>
-            <a:ext cx="1234440" cy="329184"/>
+            <a:off x="3337560" y="1207008"/>
+            <a:ext cx="1234440" cy="310896"/>
           </a:xfrm>
           <a:prstGeom prst="rect">
             <a:avLst/>
@@ -4389,8 +4406,8 @@
         </p:nvSpPr>
         <p:spPr>
           <a:xfrm>
-            <a:off x="4617720" y="1024128"/>
-            <a:ext cx="2057400" cy="365760"/>
+            <a:off x="4617720" y="1188720"/>
+            <a:ext cx="2057400" cy="347472"/>
           </a:xfrm>
           <a:prstGeom prst="rect">
             <a:avLst/>
@@ -4409,8 +4426,8 @@
         </p:nvSpPr>
         <p:spPr>
           <a:xfrm>
-            <a:off x="4663440" y="1042416"/>
-            <a:ext cx="2011680" cy="329184"/>
+            <a:off x="4663440" y="1207008"/>
+            <a:ext cx="2011680" cy="310896"/>
           </a:xfrm>
           <a:prstGeom prst="rect">
             <a:avLst/>
@@ -4448,8 +4465,8 @@
         </p:nvSpPr>
         <p:spPr>
           <a:xfrm>
-            <a:off x="6720840" y="1024128"/>
-            <a:ext cx="1965960" cy="365760"/>
+            <a:off x="6720840" y="1188720"/>
+            <a:ext cx="1965960" cy="347472"/>
           </a:xfrm>
           <a:prstGeom prst="rect">
             <a:avLst/>
@@ -4468,8 +4485,8 @@
         </p:nvSpPr>
         <p:spPr>
           <a:xfrm>
-            <a:off x="6766560" y="1042416"/>
-            <a:ext cx="1920240" cy="329184"/>
+            <a:off x="6766560" y="1207008"/>
+            <a:ext cx="1920240" cy="310896"/>
           </a:xfrm>
           <a:prstGeom prst="rect">
             <a:avLst/>
@@ -4507,8 +4524,8 @@
         </p:nvSpPr>
         <p:spPr>
           <a:xfrm>
-            <a:off x="320040" y="1417320"/>
-            <a:ext cx="1920240" cy="365760"/>
+            <a:off x="320040" y="1572768"/>
+            <a:ext cx="1920240" cy="347472"/>
           </a:xfrm>
           <a:prstGeom prst="rect">
             <a:avLst/>
@@ -4527,8 +4544,8 @@
         </p:nvSpPr>
         <p:spPr>
           <a:xfrm>
-            <a:off x="365760" y="1435608"/>
-            <a:ext cx="1874520" cy="329184"/>
+            <a:off x="365760" y="1591056"/>
+            <a:ext cx="1874520" cy="310896"/>
           </a:xfrm>
           <a:prstGeom prst="rect">
             <a:avLst/>
@@ -4566,8 +4583,8 @@
         </p:nvSpPr>
         <p:spPr>
           <a:xfrm>
-            <a:off x="2286000" y="1417320"/>
-            <a:ext cx="960120" cy="365760"/>
+            <a:off x="2286000" y="1572768"/>
+            <a:ext cx="960120" cy="347472"/>
           </a:xfrm>
           <a:prstGeom prst="rect">
             <a:avLst/>
@@ -4586,8 +4603,8 @@
         </p:nvSpPr>
         <p:spPr>
           <a:xfrm>
-            <a:off x="2331720" y="1435608"/>
-            <a:ext cx="914400" cy="329184"/>
+            <a:off x="2331720" y="1591056"/>
+            <a:ext cx="914400" cy="310896"/>
           </a:xfrm>
           <a:prstGeom prst="rect">
             <a:avLst/>
@@ -4625,8 +4642,8 @@
         </p:nvSpPr>
         <p:spPr>
           <a:xfrm>
-            <a:off x="3291840" y="1417320"/>
-            <a:ext cx="1280160" cy="365760"/>
+            <a:off x="3291840" y="1572768"/>
+            <a:ext cx="1280160" cy="347472"/>
           </a:xfrm>
           <a:prstGeom prst="rect">
             <a:avLst/>
@@ -4645,8 +4662,8 @@
         </p:nvSpPr>
         <p:spPr>
           <a:xfrm>
-            <a:off x="3337560" y="1435608"/>
-            <a:ext cx="1234440" cy="329184"/>
+            <a:off x="3337560" y="1591056"/>
+            <a:ext cx="1234440" cy="310896"/>
           </a:xfrm>
           <a:prstGeom prst="rect">
             <a:avLst/>
@@ -4684,8 +4701,8 @@
         </p:nvSpPr>
         <p:spPr>
           <a:xfrm>
-            <a:off x="4617720" y="1417320"/>
-            <a:ext cx="2057400" cy="365760"/>
+            <a:off x="4617720" y="1572768"/>
+            <a:ext cx="2057400" cy="347472"/>
           </a:xfrm>
           <a:prstGeom prst="rect">
             <a:avLst/>
@@ -4704,8 +4721,8 @@
         </p:nvSpPr>
         <p:spPr>
           <a:xfrm>
-            <a:off x="4663440" y="1435608"/>
-            <a:ext cx="2011680" cy="329184"/>
+            <a:off x="4663440" y="1591056"/>
+            <a:ext cx="2011680" cy="310896"/>
           </a:xfrm>
           <a:prstGeom prst="rect">
             <a:avLst/>
@@ -4743,8 +4760,8 @@
         </p:nvSpPr>
         <p:spPr>
           <a:xfrm>
-            <a:off x="6720840" y="1417320"/>
-            <a:ext cx="1965960" cy="365760"/>
+            <a:off x="6720840" y="1572768"/>
+            <a:ext cx="1965960" cy="347472"/>
           </a:xfrm>
           <a:prstGeom prst="rect">
             <a:avLst/>
@@ -4763,8 +4780,8 @@
         </p:nvSpPr>
         <p:spPr>
           <a:xfrm>
-            <a:off x="6766560" y="1435608"/>
-            <a:ext cx="1920240" cy="329184"/>
+            <a:off x="6766560" y="1591056"/>
+            <a:ext cx="1920240" cy="310896"/>
           </a:xfrm>
           <a:prstGeom prst="rect">
             <a:avLst/>
@@ -4802,8 +4819,8 @@
         </p:nvSpPr>
         <p:spPr>
           <a:xfrm>
-            <a:off x="320040" y="1801368"/>
-            <a:ext cx="1920240" cy="365760"/>
+            <a:off x="320040" y="1938528"/>
+            <a:ext cx="1920240" cy="347472"/>
           </a:xfrm>
           <a:prstGeom prst="rect">
             <a:avLst/>
@@ -4822,8 +4839,8 @@
         </p:nvSpPr>
         <p:spPr>
           <a:xfrm>
-            <a:off x="365760" y="1819656"/>
-            <a:ext cx="1874520" cy="329184"/>
+            <a:off x="365760" y="1956816"/>
+            <a:ext cx="1874520" cy="310896"/>
           </a:xfrm>
           <a:prstGeom prst="rect">
             <a:avLst/>
@@ -4861,8 +4878,8 @@
         </p:nvSpPr>
         <p:spPr>
           <a:xfrm>
-            <a:off x="2286000" y="1801368"/>
-            <a:ext cx="960120" cy="365760"/>
+            <a:off x="2286000" y="1938528"/>
+            <a:ext cx="960120" cy="347472"/>
           </a:xfrm>
           <a:prstGeom prst="rect">
             <a:avLst/>
@@ -4881,8 +4898,8 @@
         </p:nvSpPr>
         <p:spPr>
           <a:xfrm>
-            <a:off x="2331720" y="1819656"/>
-            <a:ext cx="914400" cy="329184"/>
+            <a:off x="2331720" y="1956816"/>
+            <a:ext cx="914400" cy="310896"/>
           </a:xfrm>
           <a:prstGeom prst="rect">
             <a:avLst/>
@@ -4920,8 +4937,8 @@
         </p:nvSpPr>
         <p:spPr>
           <a:xfrm>
-            <a:off x="3291840" y="1801368"/>
-            <a:ext cx="1280160" cy="365760"/>
+            <a:off x="3291840" y="1938528"/>
+            <a:ext cx="1280160" cy="347472"/>
           </a:xfrm>
           <a:prstGeom prst="rect">
             <a:avLst/>
@@ -4940,8 +4957,8 @@
         </p:nvSpPr>
         <p:spPr>
           <a:xfrm>
-            <a:off x="3337560" y="1819656"/>
-            <a:ext cx="1234440" cy="329184"/>
+            <a:off x="3337560" y="1956816"/>
+            <a:ext cx="1234440" cy="310896"/>
           </a:xfrm>
           <a:prstGeom prst="rect">
             <a:avLst/>
@@ -4979,8 +4996,8 @@
         </p:nvSpPr>
         <p:spPr>
           <a:xfrm>
-            <a:off x="4617720" y="1801368"/>
-            <a:ext cx="2057400" cy="365760"/>
+            <a:off x="4617720" y="1938528"/>
+            <a:ext cx="2057400" cy="347472"/>
           </a:xfrm>
           <a:prstGeom prst="rect">
             <a:avLst/>
@@ -4999,8 +5016,8 @@
         </p:nvSpPr>
         <p:spPr>
           <a:xfrm>
-            <a:off x="4663440" y="1819656"/>
-            <a:ext cx="2011680" cy="329184"/>
+            <a:off x="4663440" y="1956816"/>
+            <a:ext cx="2011680" cy="310896"/>
           </a:xfrm>
           <a:prstGeom prst="rect">
             <a:avLst/>
@@ -5038,8 +5055,8 @@
         </p:nvSpPr>
         <p:spPr>
           <a:xfrm>
-            <a:off x="6720840" y="1801368"/>
-            <a:ext cx="1965960" cy="365760"/>
+            <a:off x="6720840" y="1938528"/>
+            <a:ext cx="1965960" cy="347472"/>
           </a:xfrm>
           <a:prstGeom prst="rect">
             <a:avLst/>
@@ -5058,8 +5075,8 @@
         </p:nvSpPr>
         <p:spPr>
           <a:xfrm>
-            <a:off x="6766560" y="1819656"/>
-            <a:ext cx="1920240" cy="329184"/>
+            <a:off x="6766560" y="1956816"/>
+            <a:ext cx="1920240" cy="310896"/>
           </a:xfrm>
           <a:prstGeom prst="rect">
             <a:avLst/>
@@ -5097,8 +5114,8 @@
         </p:nvSpPr>
         <p:spPr>
           <a:xfrm>
-            <a:off x="320040" y="2185416"/>
-            <a:ext cx="1920240" cy="365760"/>
+            <a:off x="320040" y="2304288"/>
+            <a:ext cx="1920240" cy="347472"/>
           </a:xfrm>
           <a:prstGeom prst="rect">
             <a:avLst/>
@@ -5117,8 +5134,8 @@
         </p:nvSpPr>
         <p:spPr>
           <a:xfrm>
-            <a:off x="365760" y="2203704"/>
-            <a:ext cx="1874520" cy="329184"/>
+            <a:off x="365760" y="2322576"/>
+            <a:ext cx="1874520" cy="310896"/>
           </a:xfrm>
           <a:prstGeom prst="rect">
             <a:avLst/>
@@ -5156,8 +5173,8 @@
         </p:nvSpPr>
         <p:spPr>
           <a:xfrm>
-            <a:off x="2286000" y="2185416"/>
-            <a:ext cx="960120" cy="365760"/>
+            <a:off x="2286000" y="2304288"/>
+            <a:ext cx="960120" cy="347472"/>
           </a:xfrm>
           <a:prstGeom prst="rect">
             <a:avLst/>
@@ -5176,8 +5193,8 @@
         </p:nvSpPr>
         <p:spPr>
           <a:xfrm>
-            <a:off x="2331720" y="2203704"/>
-            <a:ext cx="914400" cy="329184"/>
+            <a:off x="2331720" y="2322576"/>
+            <a:ext cx="914400" cy="310896"/>
           </a:xfrm>
           <a:prstGeom prst="rect">
             <a:avLst/>
@@ -5215,8 +5232,8 @@
         </p:nvSpPr>
         <p:spPr>
           <a:xfrm>
-            <a:off x="3291840" y="2185416"/>
-            <a:ext cx="1280160" cy="365760"/>
+            <a:off x="3291840" y="2304288"/>
+            <a:ext cx="1280160" cy="347472"/>
           </a:xfrm>
           <a:prstGeom prst="rect">
             <a:avLst/>
@@ -5235,8 +5252,8 @@
         </p:nvSpPr>
         <p:spPr>
           <a:xfrm>
-            <a:off x="3337560" y="2203704"/>
-            <a:ext cx="1234440" cy="329184"/>
+            <a:off x="3337560" y="2322576"/>
+            <a:ext cx="1234440" cy="310896"/>
           </a:xfrm>
           <a:prstGeom prst="rect">
             <a:avLst/>
@@ -5274,8 +5291,8 @@
         </p:nvSpPr>
         <p:spPr>
           <a:xfrm>
-            <a:off x="4617720" y="2185416"/>
-            <a:ext cx="2057400" cy="365760"/>
+            <a:off x="4617720" y="2304288"/>
+            <a:ext cx="2057400" cy="347472"/>
           </a:xfrm>
           <a:prstGeom prst="rect">
             <a:avLst/>
@@ -5294,8 +5311,8 @@
         </p:nvSpPr>
         <p:spPr>
           <a:xfrm>
-            <a:off x="4663440" y="2203704"/>
-            <a:ext cx="2011680" cy="329184"/>
+            <a:off x="4663440" y="2322576"/>
+            <a:ext cx="2011680" cy="310896"/>
           </a:xfrm>
           <a:prstGeom prst="rect">
             <a:avLst/>
@@ -5333,8 +5350,8 @@
         </p:nvSpPr>
         <p:spPr>
           <a:xfrm>
-            <a:off x="6720840" y="2185416"/>
-            <a:ext cx="1965960" cy="365760"/>
+            <a:off x="6720840" y="2304288"/>
+            <a:ext cx="1965960" cy="347472"/>
           </a:xfrm>
           <a:prstGeom prst="rect">
             <a:avLst/>
@@ -5353,8 +5370,8 @@
         </p:nvSpPr>
         <p:spPr>
           <a:xfrm>
-            <a:off x="6766560" y="2203704"/>
-            <a:ext cx="1920240" cy="329184"/>
+            <a:off x="6766560" y="2322576"/>
+            <a:ext cx="1920240" cy="310896"/>
           </a:xfrm>
           <a:prstGeom prst="rect">
             <a:avLst/>
@@ -5392,8 +5409,8 @@
         </p:nvSpPr>
         <p:spPr>
           <a:xfrm>
-            <a:off x="320040" y="2569464"/>
-            <a:ext cx="1920240" cy="365760"/>
+            <a:off x="320040" y="2670048"/>
+            <a:ext cx="1920240" cy="347472"/>
           </a:xfrm>
           <a:prstGeom prst="rect">
             <a:avLst/>
@@ -5412,8 +5429,8 @@
         </p:nvSpPr>
         <p:spPr>
           <a:xfrm>
-            <a:off x="365760" y="2587752"/>
-            <a:ext cx="1874520" cy="329184"/>
+            <a:off x="365760" y="2688336"/>
+            <a:ext cx="1874520" cy="310896"/>
           </a:xfrm>
           <a:prstGeom prst="rect">
             <a:avLst/>
@@ -5451,8 +5468,8 @@
         </p:nvSpPr>
         <p:spPr>
           <a:xfrm>
-            <a:off x="2286000" y="2569464"/>
-            <a:ext cx="960120" cy="365760"/>
+            <a:off x="2286000" y="2670048"/>
+            <a:ext cx="960120" cy="347472"/>
           </a:xfrm>
           <a:prstGeom prst="rect">
             <a:avLst/>
@@ -5471,8 +5488,8 @@
         </p:nvSpPr>
         <p:spPr>
           <a:xfrm>
-            <a:off x="2331720" y="2587752"/>
-            <a:ext cx="914400" cy="329184"/>
+            <a:off x="2331720" y="2688336"/>
+            <a:ext cx="914400" cy="310896"/>
           </a:xfrm>
           <a:prstGeom prst="rect">
             <a:avLst/>
@@ -5510,8 +5527,8 @@
         </p:nvSpPr>
         <p:spPr>
           <a:xfrm>
-            <a:off x="3291840" y="2569464"/>
-            <a:ext cx="1280160" cy="365760"/>
+            <a:off x="3291840" y="2670048"/>
+            <a:ext cx="1280160" cy="347472"/>
           </a:xfrm>
           <a:prstGeom prst="rect">
             <a:avLst/>
@@ -5530,8 +5547,8 @@
         </p:nvSpPr>
         <p:spPr>
           <a:xfrm>
-            <a:off x="3337560" y="2587752"/>
-            <a:ext cx="1234440" cy="329184"/>
+            <a:off x="3337560" y="2688336"/>
+            <a:ext cx="1234440" cy="310896"/>
           </a:xfrm>
           <a:prstGeom prst="rect">
             <a:avLst/>
@@ -5569,8 +5586,8 @@
         </p:nvSpPr>
         <p:spPr>
           <a:xfrm>
-            <a:off x="4617720" y="2569464"/>
-            <a:ext cx="2057400" cy="365760"/>
+            <a:off x="4617720" y="2670048"/>
+            <a:ext cx="2057400" cy="347472"/>
           </a:xfrm>
           <a:prstGeom prst="rect">
             <a:avLst/>
@@ -5589,8 +5606,8 @@
         </p:nvSpPr>
         <p:spPr>
           <a:xfrm>
-            <a:off x="4663440" y="2587752"/>
-            <a:ext cx="2011680" cy="329184"/>
+            <a:off x="4663440" y="2688336"/>
+            <a:ext cx="2011680" cy="310896"/>
           </a:xfrm>
           <a:prstGeom prst="rect">
             <a:avLst/>
@@ -5628,8 +5645,8 @@
         </p:nvSpPr>
         <p:spPr>
           <a:xfrm>
-            <a:off x="6720840" y="2569464"/>
-            <a:ext cx="1965960" cy="365760"/>
+            <a:off x="6720840" y="2670048"/>
+            <a:ext cx="1965960" cy="347472"/>
           </a:xfrm>
           <a:prstGeom prst="rect">
             <a:avLst/>
@@ -5648,8 +5665,8 @@
         </p:nvSpPr>
         <p:spPr>
           <a:xfrm>
-            <a:off x="6766560" y="2587752"/>
-            <a:ext cx="1920240" cy="329184"/>
+            <a:off x="6766560" y="2688336"/>
+            <a:ext cx="1920240" cy="310896"/>
           </a:xfrm>
           <a:prstGeom prst="rect">
             <a:avLst/>
@@ -5687,8 +5704,8 @@
         </p:nvSpPr>
         <p:spPr>
           <a:xfrm>
-            <a:off x="320040" y="2953512"/>
-            <a:ext cx="1920240" cy="365760"/>
+            <a:off x="320040" y="3035808"/>
+            <a:ext cx="1920240" cy="347472"/>
           </a:xfrm>
           <a:prstGeom prst="rect">
             <a:avLst/>
@@ -5707,8 +5724,8 @@
         </p:nvSpPr>
         <p:spPr>
           <a:xfrm>
-            <a:off x="365760" y="2971800"/>
-            <a:ext cx="1874520" cy="329184"/>
+            <a:off x="365760" y="3054096"/>
+            <a:ext cx="1874520" cy="310896"/>
           </a:xfrm>
           <a:prstGeom prst="rect">
             <a:avLst/>
@@ -5746,8 +5763,8 @@
         </p:nvSpPr>
         <p:spPr>
           <a:xfrm>
-            <a:off x="2286000" y="2953512"/>
-            <a:ext cx="960120" cy="365760"/>
+            <a:off x="2286000" y="3035808"/>
+            <a:ext cx="960120" cy="347472"/>
           </a:xfrm>
           <a:prstGeom prst="rect">
             <a:avLst/>
@@ -5766,8 +5783,8 @@
         </p:nvSpPr>
         <p:spPr>
           <a:xfrm>
-            <a:off x="2331720" y="2971800"/>
-            <a:ext cx="914400" cy="329184"/>
+            <a:off x="2331720" y="3054096"/>
+            <a:ext cx="914400" cy="310896"/>
           </a:xfrm>
           <a:prstGeom prst="rect">
             <a:avLst/>
@@ -5805,8 +5822,8 @@
         </p:nvSpPr>
         <p:spPr>
           <a:xfrm>
-            <a:off x="3291840" y="2953512"/>
-            <a:ext cx="1280160" cy="365760"/>
+            <a:off x="3291840" y="3035808"/>
+            <a:ext cx="1280160" cy="347472"/>
           </a:xfrm>
           <a:prstGeom prst="rect">
             <a:avLst/>
@@ -5825,8 +5842,8 @@
         </p:nvSpPr>
         <p:spPr>
           <a:xfrm>
-            <a:off x="3337560" y="2971800"/>
-            <a:ext cx="1234440" cy="329184"/>
+            <a:off x="3337560" y="3054096"/>
+            <a:ext cx="1234440" cy="310896"/>
           </a:xfrm>
           <a:prstGeom prst="rect">
             <a:avLst/>
@@ -5864,8 +5881,8 @@
         </p:nvSpPr>
         <p:spPr>
           <a:xfrm>
-            <a:off x="4617720" y="2953512"/>
-            <a:ext cx="2057400" cy="365760"/>
+            <a:off x="4617720" y="3035808"/>
+            <a:ext cx="2057400" cy="347472"/>
           </a:xfrm>
           <a:prstGeom prst="rect">
             <a:avLst/>
@@ -5884,8 +5901,8 @@
         </p:nvSpPr>
         <p:spPr>
           <a:xfrm>
-            <a:off x="4663440" y="2971800"/>
-            <a:ext cx="2011680" cy="329184"/>
+            <a:off x="4663440" y="3054096"/>
+            <a:ext cx="2011680" cy="310896"/>
           </a:xfrm>
           <a:prstGeom prst="rect">
             <a:avLst/>
@@ -5923,8 +5940,8 @@
         </p:nvSpPr>
         <p:spPr>
           <a:xfrm>
-            <a:off x="6720840" y="2953512"/>
-            <a:ext cx="1965960" cy="365760"/>
+            <a:off x="6720840" y="3035808"/>
+            <a:ext cx="1965960" cy="347472"/>
           </a:xfrm>
           <a:prstGeom prst="rect">
             <a:avLst/>
@@ -5943,8 +5960,8 @@
         </p:nvSpPr>
         <p:spPr>
           <a:xfrm>
-            <a:off x="6766560" y="2971800"/>
-            <a:ext cx="1920240" cy="329184"/>
+            <a:off x="6766560" y="3054096"/>
+            <a:ext cx="1920240" cy="310896"/>
           </a:xfrm>
           <a:prstGeom prst="rect">
             <a:avLst/>
@@ -5982,8 +5999,8 @@
         </p:nvSpPr>
         <p:spPr>
           <a:xfrm>
-            <a:off x="320040" y="3337560"/>
-            <a:ext cx="1920240" cy="365760"/>
+            <a:off x="320040" y="3401568"/>
+            <a:ext cx="1920240" cy="347472"/>
           </a:xfrm>
           <a:prstGeom prst="rect">
             <a:avLst/>
@@ -6002,8 +6019,8 @@
         </p:nvSpPr>
         <p:spPr>
           <a:xfrm>
-            <a:off x="365760" y="3355848"/>
-            <a:ext cx="1874520" cy="329184"/>
+            <a:off x="365760" y="3419856"/>
+            <a:ext cx="1874520" cy="310896"/>
           </a:xfrm>
           <a:prstGeom prst="rect">
             <a:avLst/>
@@ -6041,8 +6058,8 @@
         </p:nvSpPr>
         <p:spPr>
           <a:xfrm>
-            <a:off x="2286000" y="3337560"/>
-            <a:ext cx="960120" cy="365760"/>
+            <a:off x="2286000" y="3401568"/>
+            <a:ext cx="960120" cy="347472"/>
           </a:xfrm>
           <a:prstGeom prst="rect">
             <a:avLst/>
@@ -6061,8 +6078,8 @@
         </p:nvSpPr>
         <p:spPr>
           <a:xfrm>
-            <a:off x="2331720" y="3355848"/>
-            <a:ext cx="914400" cy="329184"/>
+            <a:off x="2331720" y="3419856"/>
+            <a:ext cx="914400" cy="310896"/>
           </a:xfrm>
           <a:prstGeom prst="rect">
             <a:avLst/>
@@ -6100,8 +6117,8 @@
         </p:nvSpPr>
         <p:spPr>
           <a:xfrm>
-            <a:off x="3291840" y="3337560"/>
-            <a:ext cx="1280160" cy="365760"/>
+            <a:off x="3291840" y="3401568"/>
+            <a:ext cx="1280160" cy="347472"/>
           </a:xfrm>
           <a:prstGeom prst="rect">
             <a:avLst/>
@@ -6120,8 +6137,8 @@
         </p:nvSpPr>
         <p:spPr>
           <a:xfrm>
-            <a:off x="3337560" y="3355848"/>
-            <a:ext cx="1234440" cy="329184"/>
+            <a:off x="3337560" y="3419856"/>
+            <a:ext cx="1234440" cy="310896"/>
           </a:xfrm>
           <a:prstGeom prst="rect">
             <a:avLst/>
@@ -6159,8 +6176,8 @@
         </p:nvSpPr>
         <p:spPr>
           <a:xfrm>
-            <a:off x="4617720" y="3337560"/>
-            <a:ext cx="2057400" cy="365760"/>
+            <a:off x="4617720" y="3401568"/>
+            <a:ext cx="2057400" cy="347472"/>
           </a:xfrm>
           <a:prstGeom prst="rect">
             <a:avLst/>
@@ -6179,8 +6196,8 @@
         </p:nvSpPr>
         <p:spPr>
           <a:xfrm>
-            <a:off x="4663440" y="3355848"/>
-            <a:ext cx="2011680" cy="329184"/>
+            <a:off x="4663440" y="3419856"/>
+            <a:ext cx="2011680" cy="310896"/>
           </a:xfrm>
           <a:prstGeom prst="rect">
             <a:avLst/>
@@ -6218,8 +6235,8 @@
         </p:nvSpPr>
         <p:spPr>
           <a:xfrm>
-            <a:off x="6720840" y="3337560"/>
-            <a:ext cx="1965960" cy="365760"/>
+            <a:off x="6720840" y="3401568"/>
+            <a:ext cx="1965960" cy="347472"/>
           </a:xfrm>
           <a:prstGeom prst="rect">
             <a:avLst/>
@@ -6238,8 +6255,8 @@
         </p:nvSpPr>
         <p:spPr>
           <a:xfrm>
-            <a:off x="6766560" y="3355848"/>
-            <a:ext cx="1920240" cy="329184"/>
+            <a:off x="6766560" y="3419856"/>
+            <a:ext cx="1920240" cy="310896"/>
           </a:xfrm>
           <a:prstGeom prst="rect">
             <a:avLst/>
@@ -6277,8 +6294,8 @@
         </p:nvSpPr>
         <p:spPr>
           <a:xfrm>
-            <a:off x="320040" y="3721608"/>
-            <a:ext cx="1920240" cy="365760"/>
+            <a:off x="320040" y="3767328"/>
+            <a:ext cx="1920240" cy="347472"/>
           </a:xfrm>
           <a:prstGeom prst="rect">
             <a:avLst/>
@@ -6297,8 +6314,8 @@
         </p:nvSpPr>
         <p:spPr>
           <a:xfrm>
-            <a:off x="365760" y="3739896"/>
-            <a:ext cx="1874520" cy="329184"/>
+            <a:off x="365760" y="3785616"/>
+            <a:ext cx="1874520" cy="310896"/>
           </a:xfrm>
           <a:prstGeom prst="rect">
             <a:avLst/>
@@ -6336,8 +6353,8 @@
         </p:nvSpPr>
         <p:spPr>
           <a:xfrm>
-            <a:off x="2286000" y="3721608"/>
-            <a:ext cx="960120" cy="365760"/>
+            <a:off x="2286000" y="3767328"/>
+            <a:ext cx="960120" cy="347472"/>
           </a:xfrm>
           <a:prstGeom prst="rect">
             <a:avLst/>
@@ -6356,8 +6373,8 @@
         </p:nvSpPr>
         <p:spPr>
           <a:xfrm>
-            <a:off x="2331720" y="3739896"/>
-            <a:ext cx="914400" cy="329184"/>
+            <a:off x="2331720" y="3785616"/>
+            <a:ext cx="914400" cy="310896"/>
           </a:xfrm>
           <a:prstGeom prst="rect">
             <a:avLst/>
@@ -6395,8 +6412,8 @@
         </p:nvSpPr>
         <p:spPr>
           <a:xfrm>
-            <a:off x="3291840" y="3721608"/>
-            <a:ext cx="1280160" cy="365760"/>
+            <a:off x="3291840" y="3767328"/>
+            <a:ext cx="1280160" cy="347472"/>
           </a:xfrm>
           <a:prstGeom prst="rect">
             <a:avLst/>
@@ -6415,8 +6432,8 @@
         </p:nvSpPr>
         <p:spPr>
           <a:xfrm>
-            <a:off x="3337560" y="3739896"/>
-            <a:ext cx="1234440" cy="329184"/>
+            <a:off x="3337560" y="3785616"/>
+            <a:ext cx="1234440" cy="310896"/>
           </a:xfrm>
           <a:prstGeom prst="rect">
             <a:avLst/>
@@ -6454,8 +6471,8 @@
         </p:nvSpPr>
         <p:spPr>
           <a:xfrm>
-            <a:off x="4617720" y="3721608"/>
-            <a:ext cx="2057400" cy="365760"/>
+            <a:off x="4617720" y="3767328"/>
+            <a:ext cx="2057400" cy="347472"/>
           </a:xfrm>
           <a:prstGeom prst="rect">
             <a:avLst/>
@@ -6474,8 +6491,8 @@
         </p:nvSpPr>
         <p:spPr>
           <a:xfrm>
-            <a:off x="4663440" y="3739896"/>
-            <a:ext cx="2011680" cy="329184"/>
+            <a:off x="4663440" y="3785616"/>
+            <a:ext cx="2011680" cy="310896"/>
           </a:xfrm>
           <a:prstGeom prst="rect">
             <a:avLst/>
@@ -6513,8 +6530,8 @@
         </p:nvSpPr>
         <p:spPr>
           <a:xfrm>
-            <a:off x="6720840" y="3721608"/>
-            <a:ext cx="1965960" cy="365760"/>
+            <a:off x="6720840" y="3767328"/>
+            <a:ext cx="1965960" cy="347472"/>
           </a:xfrm>
           <a:prstGeom prst="rect">
             <a:avLst/>
@@ -6533,8 +6550,8 @@
         </p:nvSpPr>
         <p:spPr>
           <a:xfrm>
-            <a:off x="6766560" y="3739896"/>
-            <a:ext cx="1920240" cy="329184"/>
+            <a:off x="6766560" y="3785616"/>
+            <a:ext cx="1920240" cy="310896"/>
           </a:xfrm>
           <a:prstGeom prst="rect">
             <a:avLst/>
@@ -6572,8 +6589,8 @@
         </p:nvSpPr>
         <p:spPr>
           <a:xfrm>
-            <a:off x="320040" y="4105656"/>
-            <a:ext cx="1920240" cy="365760"/>
+            <a:off x="320040" y="4133088"/>
+            <a:ext cx="1920240" cy="347472"/>
           </a:xfrm>
           <a:prstGeom prst="rect">
             <a:avLst/>
@@ -6592,8 +6609,8 @@
         </p:nvSpPr>
         <p:spPr>
           <a:xfrm>
-            <a:off x="365760" y="4123944"/>
-            <a:ext cx="1874520" cy="329184"/>
+            <a:off x="365760" y="4151376"/>
+            <a:ext cx="1874520" cy="310896"/>
           </a:xfrm>
           <a:prstGeom prst="rect">
             <a:avLst/>
@@ -6631,8 +6648,8 @@
         </p:nvSpPr>
         <p:spPr>
           <a:xfrm>
-            <a:off x="2286000" y="4105656"/>
-            <a:ext cx="960120" cy="365760"/>
+            <a:off x="2286000" y="4133088"/>
+            <a:ext cx="960120" cy="347472"/>
           </a:xfrm>
           <a:prstGeom prst="rect">
             <a:avLst/>
@@ -6651,8 +6668,8 @@
         </p:nvSpPr>
         <p:spPr>
           <a:xfrm>
-            <a:off x="2331720" y="4123944"/>
-            <a:ext cx="914400" cy="329184"/>
+            <a:off x="2331720" y="4151376"/>
+            <a:ext cx="914400" cy="310896"/>
           </a:xfrm>
           <a:prstGeom prst="rect">
             <a:avLst/>
@@ -6690,8 +6707,8 @@
         </p:nvSpPr>
         <p:spPr>
           <a:xfrm>
-            <a:off x="3291840" y="4105656"/>
-            <a:ext cx="1280160" cy="365760"/>
+            <a:off x="3291840" y="4133088"/>
+            <a:ext cx="1280160" cy="347472"/>
           </a:xfrm>
           <a:prstGeom prst="rect">
             <a:avLst/>
@@ -6710,8 +6727,8 @@
         </p:nvSpPr>
         <p:spPr>
           <a:xfrm>
-            <a:off x="3337560" y="4123944"/>
-            <a:ext cx="1234440" cy="329184"/>
+            <a:off x="3337560" y="4151376"/>
+            <a:ext cx="1234440" cy="310896"/>
           </a:xfrm>
           <a:prstGeom prst="rect">
             <a:avLst/>
@@ -6749,8 +6766,8 @@
         </p:nvSpPr>
         <p:spPr>
           <a:xfrm>
-            <a:off x="4617720" y="4105656"/>
-            <a:ext cx="2057400" cy="365760"/>
+            <a:off x="4617720" y="4133088"/>
+            <a:ext cx="2057400" cy="347472"/>
           </a:xfrm>
           <a:prstGeom prst="rect">
             <a:avLst/>
@@ -6769,8 +6786,8 @@
         </p:nvSpPr>
         <p:spPr>
           <a:xfrm>
-            <a:off x="4663440" y="4123944"/>
-            <a:ext cx="2011680" cy="329184"/>
+            <a:off x="4663440" y="4151376"/>
+            <a:ext cx="2011680" cy="310896"/>
           </a:xfrm>
           <a:prstGeom prst="rect">
             <a:avLst/>
@@ -6808,8 +6825,8 @@
         </p:nvSpPr>
         <p:spPr>
           <a:xfrm>
-            <a:off x="6720840" y="4105656"/>
-            <a:ext cx="1965960" cy="365760"/>
+            <a:off x="6720840" y="4133088"/>
+            <a:ext cx="1965960" cy="347472"/>
           </a:xfrm>
           <a:prstGeom prst="rect">
             <a:avLst/>
@@ -6828,8 +6845,8 @@
         </p:nvSpPr>
         <p:spPr>
           <a:xfrm>
-            <a:off x="6766560" y="4123944"/>
-            <a:ext cx="1920240" cy="329184"/>
+            <a:off x="6766560" y="4151376"/>
+            <a:ext cx="1920240" cy="310896"/>
           </a:xfrm>
           <a:prstGeom prst="rect">
             <a:avLst/>
@@ -6909,7 +6926,7 @@
                 <a:ea typeface="Calibri" pitchFamily="34" charset="-122"/>
                 <a:cs typeface="Calibri" pitchFamily="34" charset="-120"/>
               </a:rPr>
-              <a:t>Authentic: range extends up an octave from final; Plagal: range spans both sides of final</a:t>
+              <a:t>Authentic: range extends octave up from final; Plagal: range spans both sides</a:t>
             </a:r>
             <a:endParaRPr lang="en-US" sz="1400" dirty="0"/>
           </a:p>
@@ -7153,7 +7170,7 @@
         <p:spPr>
           <a:xfrm>
             <a:off x="411480" y="1591056"/>
-            <a:ext cx="4389120" cy="502920"/>
+            <a:ext cx="4389120" cy="658368"/>
           </a:xfrm>
           <a:prstGeom prst="rect">
             <a:avLst/>
@@ -7208,8 +7225,8 @@
         </p:nvSpPr>
         <p:spPr>
           <a:xfrm>
-            <a:off x="502920" y="2148840"/>
-            <a:ext cx="621792" cy="822960"/>
+            <a:off x="502920" y="2304288"/>
+            <a:ext cx="621792" cy="749808"/>
           </a:xfrm>
           <a:prstGeom prst="rect">
             <a:avLst/>
@@ -7228,7 +7245,7 @@
         </p:nvSpPr>
         <p:spPr>
           <a:xfrm>
-            <a:off x="502920" y="2194560"/>
+            <a:off x="502920" y="2350008"/>
             <a:ext cx="621792" cy="384048"/>
           </a:xfrm>
           <a:prstGeom prst="rect">
@@ -7267,8 +7284,8 @@
         </p:nvSpPr>
         <p:spPr>
           <a:xfrm>
-            <a:off x="502920" y="2578608"/>
-            <a:ext cx="621792" cy="347472"/>
+            <a:off x="502920" y="2706624"/>
+            <a:ext cx="621792" cy="329184"/>
           </a:xfrm>
           <a:prstGeom prst="rect">
             <a:avLst/>
@@ -7306,8 +7323,8 @@
         </p:nvSpPr>
         <p:spPr>
           <a:xfrm>
-            <a:off x="1234440" y="2148840"/>
-            <a:ext cx="621792" cy="822960"/>
+            <a:off x="1234440" y="2304288"/>
+            <a:ext cx="621792" cy="749808"/>
           </a:xfrm>
           <a:prstGeom prst="rect">
             <a:avLst/>
@@ -7326,7 +7343,7 @@
         </p:nvSpPr>
         <p:spPr>
           <a:xfrm>
-            <a:off x="1234440" y="2194560"/>
+            <a:off x="1234440" y="2350008"/>
             <a:ext cx="621792" cy="384048"/>
           </a:xfrm>
           <a:prstGeom prst="rect">
@@ -7365,8 +7382,8 @@
         </p:nvSpPr>
         <p:spPr>
           <a:xfrm>
-            <a:off x="1234440" y="2578608"/>
-            <a:ext cx="621792" cy="347472"/>
+            <a:off x="1234440" y="2706624"/>
+            <a:ext cx="621792" cy="329184"/>
           </a:xfrm>
           <a:prstGeom prst="rect">
             <a:avLst/>
@@ -7404,8 +7421,8 @@
         </p:nvSpPr>
         <p:spPr>
           <a:xfrm>
-            <a:off x="1965960" y="2148840"/>
-            <a:ext cx="621792" cy="822960"/>
+            <a:off x="1965960" y="2304288"/>
+            <a:ext cx="621792" cy="749808"/>
           </a:xfrm>
           <a:prstGeom prst="rect">
             <a:avLst/>
@@ -7424,7 +7441,7 @@
         </p:nvSpPr>
         <p:spPr>
           <a:xfrm>
-            <a:off x="1965960" y="2194560"/>
+            <a:off x="1965960" y="2350008"/>
             <a:ext cx="621792" cy="384048"/>
           </a:xfrm>
           <a:prstGeom prst="rect">
@@ -7463,8 +7480,8 @@
         </p:nvSpPr>
         <p:spPr>
           <a:xfrm>
-            <a:off x="1965960" y="2578608"/>
-            <a:ext cx="621792" cy="347472"/>
+            <a:off x="1965960" y="2706624"/>
+            <a:ext cx="621792" cy="329184"/>
           </a:xfrm>
           <a:prstGeom prst="rect">
             <a:avLst/>
@@ -7502,8 +7519,8 @@
         </p:nvSpPr>
         <p:spPr>
           <a:xfrm>
-            <a:off x="2697480" y="2148840"/>
-            <a:ext cx="621792" cy="822960"/>
+            <a:off x="2697480" y="2304288"/>
+            <a:ext cx="621792" cy="749808"/>
           </a:xfrm>
           <a:prstGeom prst="rect">
             <a:avLst/>
@@ -7522,7 +7539,7 @@
         </p:nvSpPr>
         <p:spPr>
           <a:xfrm>
-            <a:off x="2697480" y="2194560"/>
+            <a:off x="2697480" y="2350008"/>
             <a:ext cx="621792" cy="384048"/>
           </a:xfrm>
           <a:prstGeom prst="rect">
@@ -7561,8 +7578,8 @@
         </p:nvSpPr>
         <p:spPr>
           <a:xfrm>
-            <a:off x="2697480" y="2578608"/>
-            <a:ext cx="621792" cy="347472"/>
+            <a:off x="2697480" y="2706624"/>
+            <a:ext cx="621792" cy="329184"/>
           </a:xfrm>
           <a:prstGeom prst="rect">
             <a:avLst/>
@@ -7600,8 +7617,8 @@
         </p:nvSpPr>
         <p:spPr>
           <a:xfrm>
-            <a:off x="3429000" y="2148840"/>
-            <a:ext cx="621792" cy="822960"/>
+            <a:off x="3429000" y="2304288"/>
+            <a:ext cx="621792" cy="749808"/>
           </a:xfrm>
           <a:prstGeom prst="rect">
             <a:avLst/>
@@ -7620,7 +7637,7 @@
         </p:nvSpPr>
         <p:spPr>
           <a:xfrm>
-            <a:off x="3429000" y="2194560"/>
+            <a:off x="3429000" y="2350008"/>
             <a:ext cx="621792" cy="384048"/>
           </a:xfrm>
           <a:prstGeom prst="rect">
@@ -7659,8 +7676,8 @@
         </p:nvSpPr>
         <p:spPr>
           <a:xfrm>
-            <a:off x="3429000" y="2578608"/>
-            <a:ext cx="621792" cy="347472"/>
+            <a:off x="3429000" y="2706624"/>
+            <a:ext cx="621792" cy="329184"/>
           </a:xfrm>
           <a:prstGeom prst="rect">
             <a:avLst/>
@@ -7698,8 +7715,8 @@
         </p:nvSpPr>
         <p:spPr>
           <a:xfrm>
-            <a:off x="4160520" y="2148840"/>
-            <a:ext cx="621792" cy="822960"/>
+            <a:off x="4160520" y="2304288"/>
+            <a:ext cx="621792" cy="749808"/>
           </a:xfrm>
           <a:prstGeom prst="rect">
             <a:avLst/>
@@ -7718,7 +7735,7 @@
         </p:nvSpPr>
         <p:spPr>
           <a:xfrm>
-            <a:off x="4160520" y="2194560"/>
+            <a:off x="4160520" y="2350008"/>
             <a:ext cx="621792" cy="384048"/>
           </a:xfrm>
           <a:prstGeom prst="rect">
@@ -7757,8 +7774,8 @@
         </p:nvSpPr>
         <p:spPr>
           <a:xfrm>
-            <a:off x="4160520" y="2578608"/>
-            <a:ext cx="621792" cy="347472"/>
+            <a:off x="4160520" y="2706624"/>
+            <a:ext cx="621792" cy="329184"/>
           </a:xfrm>
           <a:prstGeom prst="rect">
             <a:avLst/>
@@ -7796,8 +7813,8 @@
         </p:nvSpPr>
         <p:spPr>
           <a:xfrm>
-            <a:off x="411480" y="3063240"/>
-            <a:ext cx="4389120" cy="1600200"/>
+            <a:off x="411480" y="3154680"/>
+            <a:ext cx="4389120" cy="1572768"/>
           </a:xfrm>
           <a:prstGeom prst="rect">
             <a:avLst/>

</xml_diff>